<commit_message>
update: regenerate presentation outputs with new Q&A pairs
Regenerated LLM outputs for Salah, Rodri and Van Dijk slides using
the updated 54 describe Q&A pairs. Outputs are now more data-focused
and avoid speculating about playing style or tactical systems.

Co-Authored-By: Claude Opus 4.6 (1M context) <noreply@anthropic.com>
</commit_message>
<xml_diff>
--- a/Physical_Analyst_Presentation.pptx
+++ b/Physical_Analyst_Presentation.pptx
@@ -5634,7 +5634,7 @@
                   <a:srgbClr val="FFFFFF"/>
                 </a:solidFill>
               </a:rPr>
-              <a:t>In the Premier League this season, Mohamed Salah has showcased excellent speed, consistently ranking among the quickest wide attackers. His acceleration is average for the position, though he shows good ability to reach sprint speed and recover pace after changes of direction. His agility and endurance are both poor for a wide attacker. This is a player whose physical profile is built around short, explosive speed.</a:t>
+              <a:t>In the Premier League this season, Mohamed Salah Ghaly shows elite Speed for Liverpool among Wide Attackers, with average Acceleration and weaknesses in Agility and Endurance. His top speed is excellent, and his average top speed is also excellent, reinforcing his ability to hit and sustain sprinting in behind. However, his change of direction frequency is below average, and his metres per minute and total distance are poor, with running distance and high-speed running distance below average. Overall, this profile describes a player whose physical impact is concentrated in short, high-speed moments rather than sustained output, making him a devastating threat in wide areas when space is available but less suited to constant high-pressing or lengthy, volume-based running.</a:t>
             </a:r>
           </a:p>
         </p:txBody>
@@ -6280,7 +6280,7 @@
                   <a:srgbClr val="FFFFFF"/>
                 </a:solidFill>
               </a:rPr>
-              <a:t>In the Premier League this season, Rodri has showcased excellent endurance capabilities among midfielders, with outstanding running distance and excellent total distance covered. His speed and acceleration are both below average, and his agility is average. His physical profile is centred entirely around sustained effort rather than explosive actions.</a:t>
+              <a:t>In the Premier League this season, Rodri presents an endurance-focused profile for Manchester City, with below-average Speed and Acceleration, average Agility, and excellent Endurance. That endurance is reflected in standout work-rate metrics: metres per minute and total distance are excellent, with running distance also well above peers. On the flip side, pace and explosive actions are weaker: top speed is below average, explosive sprint bursts and high-speed running bursts are below average to poor, and 180-degree turning speed is poor. Overall, this profile describes a midfielder whose strengths lie in sustained movement and game coverage, able to contribute through constant pressing and distribution, while pace and rapid-change abilities are limited and the role leans toward control and energy management rather than direct acceleration.</a:t>
             </a:r>
           </a:p>
         </p:txBody>
@@ -6926,7 +6926,7 @@
                   <a:srgbClr val="FFFFFF"/>
                 </a:solidFill>
               </a:rPr>
-              <a:t>Van Dijk has been a physically impressive performer for Liverpool, with excellent speed and outstanding acceleration among central defenders. His agility and endurance are both poor — he rarely changes direction and his distance output is among the lowest in the position group. This is a defender whose physical value is entirely in his pace and explosiveness.</a:t>
+              <a:t>In the Premier League this season, Virgil van Dijk has shown elite pace and acceleration for a central defender at Liverpool. His strengths lie in Speed and outstanding Acceleration, with top-end speed and explosive sprint bursts that enable rapid transitions and recoveries. However, Agility and Endurance are poor, and several movement metrics are well below peers, including metres per minute, total distance, running distance, high-speed running distance, as well as low 90-degree turning speed and change-of-direction frequency. Overall, this profile describes a defender whose value is driven by pace and explosive power, enabling effective stand-up defending and quick recoveries, but with notable constraints in multi-directional movement and sustained high-intensity running.</a:t>
             </a:r>
           </a:p>
         </p:txBody>

</xml_diff>